<commit_message>
claude-code-tutorial: task cards = prompts only; add answers.py answer key
- Stripped every hands-on task card down to just the prompt(s) to paste (a title +
  the prompt) — removed all "what to expect", framing, and "make it yours" prose.
- Added hands-on/answers.py: for each task, the reference Python code with its real
  output commented out beneath it, so anyone can see the correct answer (or run
  `python answers.py` to reproduce it). Verified end-to-end (exit 0; outputs match
  the comments; matplotlib uses the Agg backend so it is headless-safe).
- CLAUDE.md tells Claude to ignore answers.py while working a task (so it does the
  analysis itself). READMEs + the deck's lab slide now point to answers.py as the key.

Verified: hands-on is flat (CLAUDE.md, README.md, 01-09 cards, answers.py); 41 slides;
slide 36 caption fits; no artifacts (answers.py's figure is written only when run, in
the user's own dir).

Co-Authored-By: Claude Opus 4.8 (1M context) <noreply@anthropic.com>
</commit_message>
<xml_diff>
--- a/claude-code-tutorial/claude-code-tutorial.pptx
+++ b/claude-code-tutorial/claude-code-tutorial.pptx
@@ -14460,7 +14460,7 @@
                 </a:solidFill>
                 <a:latin typeface="Arial"/>
               </a:rPr>
-              <a:t>A flat folder of Markdown task cards and a </a:t>
+              <a:t>A flat folder: Markdown task cards, a </a:t>
             </a:r>
             <a:r>
               <a:rPr sz="1250" b="0" i="0">
@@ -14478,7 +14478,25 @@
                 </a:solidFill>
                 <a:latin typeface="Arial"/>
               </a:rPr>
-              <a:t> — no notebook, no setup, nothing to download.</a:t>
+              <a:t>, and an </a:t>
+            </a:r>
+            <a:r>
+              <a:rPr sz="1250" b="0" i="0">
+                <a:solidFill>
+                  <a:srgbClr val="007482"/>
+                </a:solidFill>
+                <a:latin typeface="Arial"/>
+              </a:rPr>
+              <a:t>answers.py</a:t>
+            </a:r>
+            <a:r>
+              <a:rPr sz="1250" b="0" i="0">
+                <a:solidFill>
+                  <a:srgbClr val="555A61"/>
+                </a:solidFill>
+                <a:latin typeface="Arial"/>
+              </a:rPr>
+              <a:t> key — no notebook, nothing to download.</a:t>
             </a:r>
           </a:p>
         </p:txBody>

</xml_diff>